<commit_message>
Fix PPT data accuracy and add References slide (Slide 14)
Data corrections:
- Visually impaired: 80M → ~72M (IAPB Vision Atlas 2023, India-specific)
- Colour-blind: 300M global → ~60M India (~8% of males, Colour Blind Awareness)
- Senior citizens: clarified 145M current / 347M projected by 2050 (UN 2023)
- Low-literacy: ~372M (Census 2011, 74% literacy on 1.43B population)
- Contrast White/Navy: 15.8:1 → 18.7:1 (WCAG formula, verified)
- Contrast Amber/Navy: 10.9:1 → 11.5:1 (WCAG formula, verified)
- Colour-blindness prevalence: deuteranopia 4.6%, protanopia 1% (Deeb 2004)

References slide covers 11 citations across 5 categories:
  Vision (IAPB 2023, WHO 2019), Ageing (UN 2023, MoSPI),
  Colour-blindness (Colour Blind Awareness, Deeb 2004),
  Literacy (Census 2011, NLM), Accessibility (WCAG 2.1, WebAIM, Material Design)

Co-Authored-By: Claude Sonnet 4.6 <noreply@anthropic.com>
</commit_message>
<xml_diff>
--- a/presentation/Saral-Accessible-Banking.pptx
+++ b/presentation/Saral-Accessible-Banking.pptx
@@ -18,6 +18,7 @@
     <p:sldId id="266" r:id="rId17"/>
     <p:sldId id="267" r:id="rId18"/>
     <p:sldId id="268" r:id="rId19"/>
+    <p:sldId id="269" r:id="rId20"/>
   </p:sldIdLst>
   <p:sldSz cx="12188952" cy="6858000" type="screen4x3"/>
   <p:notesSz cx="6858000" cy="9144000"/>
@@ -205,16 +206,16 @@
                 <c:formatCode>General</c:formatCode>
                 <c:ptCount val="4"/>
                 <c:pt idx="0">
-                  <c:v>80</c:v>
+                  <c:v>72</c:v>
                 </c:pt>
                 <c:pt idx="1">
-                  <c:v>300</c:v>
+                  <c:v>60</c:v>
                 </c:pt>
                 <c:pt idx="2">
-                  <c:v>300</c:v>
+                  <c:v>145</c:v>
                 </c:pt>
                 <c:pt idx="3">
-                  <c:v>400</c:v>
+                  <c:v>372</c:v>
                 </c:pt>
               </c:numCache>
             </c:numRef>
@@ -7935,7 +7936,7 @@
                 </a:solidFill>
                 <a:latin typeface="Calibri"/>
               </a:rPr>
-              <a:t>15.8:1</a:t>
+              <a:t>18.7:1</a:t>
             </a:r>
           </a:p>
         </p:txBody>
@@ -9840,6 +9841,2149 @@
 </p:sld>
 </file>
 
+<file path=ppt/slides/slide14.xml><?xml version="1.0" encoding="utf-8"?>
+<p:sld xmlns:a="http://schemas.openxmlformats.org/drawingml/2006/main" xmlns:p="http://schemas.openxmlformats.org/presentationml/2006/main" xmlns:r="http://schemas.openxmlformats.org/officeDocument/2006/relationships">
+  <p:cSld>
+    <p:spTree>
+      <p:nvGrpSpPr>
+        <p:cNvPr id="1" name=""/>
+        <p:cNvGrpSpPr/>
+        <p:nvPr/>
+      </p:nvGrpSpPr>
+      <p:grpSpPr/>
+      <p:sp>
+        <p:nvSpPr>
+          <p:cNvPr id="2" name="Rectangle 1"/>
+          <p:cNvSpPr/>
+          <p:nvPr/>
+        </p:nvSpPr>
+        <p:spPr>
+          <a:xfrm>
+            <a:off x="0" y="0"/>
+            <a:ext cx="12188952" cy="6858000"/>
+          </a:xfrm>
+          <a:prstGeom prst="rect">
+            <a:avLst/>
+          </a:prstGeom>
+          <a:solidFill>
+            <a:srgbClr val="081320"/>
+          </a:solidFill>
+          <a:ln>
+            <a:noFill/>
+          </a:ln>
+        </p:spPr>
+        <p:style>
+          <a:lnRef idx="1">
+            <a:schemeClr val="accent1"/>
+          </a:lnRef>
+          <a:fillRef idx="3">
+            <a:schemeClr val="accent1"/>
+          </a:fillRef>
+          <a:effectRef idx="2">
+            <a:schemeClr val="accent1"/>
+          </a:effectRef>
+          <a:fontRef idx="minor">
+            <a:schemeClr val="lt1"/>
+          </a:fontRef>
+        </p:style>
+        <p:txBody>
+          <a:bodyPr rtlCol="0" anchor="ctr"/>
+          <a:lstStyle/>
+          <a:p>
+            <a:pPr algn="ctr"/>
+          </a:p>
+        </p:txBody>
+      </p:sp>
+      <p:sp>
+        <p:nvSpPr>
+          <p:cNvPr id="3" name="Rectangle 2"/>
+          <p:cNvSpPr/>
+          <p:nvPr/>
+        </p:nvSpPr>
+        <p:spPr>
+          <a:xfrm>
+            <a:off x="0" y="0"/>
+            <a:ext cx="128016" cy="6858000"/>
+          </a:xfrm>
+          <a:prstGeom prst="rect">
+            <a:avLst/>
+          </a:prstGeom>
+          <a:solidFill>
+            <a:srgbClr val="FFC107"/>
+          </a:solidFill>
+          <a:ln>
+            <a:noFill/>
+          </a:ln>
+        </p:spPr>
+        <p:style>
+          <a:lnRef idx="1">
+            <a:schemeClr val="accent1"/>
+          </a:lnRef>
+          <a:fillRef idx="3">
+            <a:schemeClr val="accent1"/>
+          </a:fillRef>
+          <a:effectRef idx="2">
+            <a:schemeClr val="accent1"/>
+          </a:effectRef>
+          <a:fontRef idx="minor">
+            <a:schemeClr val="lt1"/>
+          </a:fontRef>
+        </p:style>
+        <p:txBody>
+          <a:bodyPr rtlCol="0" anchor="ctr"/>
+          <a:lstStyle/>
+          <a:p>
+            <a:pPr algn="ctr"/>
+          </a:p>
+        </p:txBody>
+      </p:sp>
+      <p:sp>
+        <p:nvSpPr>
+          <p:cNvPr id="4" name="TextBox 3"/>
+          <p:cNvSpPr txBox="1"/>
+          <p:nvPr/>
+        </p:nvSpPr>
+        <p:spPr>
+          <a:xfrm>
+            <a:off x="548640" y="320040"/>
+            <a:ext cx="9144000" cy="365760"/>
+          </a:xfrm>
+          <a:prstGeom prst="rect">
+            <a:avLst/>
+          </a:prstGeom>
+          <a:noFill/>
+        </p:spPr>
+        <p:txBody>
+          <a:bodyPr wrap="square">
+            <a:spAutoFit/>
+          </a:bodyPr>
+          <a:lstStyle/>
+          <a:p>
+            <a:pPr algn="l"/>
+            <a:r>
+              <a:rPr sz="1100" b="1" i="0">
+                <a:solidFill>
+                  <a:srgbClr val="FFC107"/>
+                </a:solidFill>
+                <a:latin typeface="Calibri"/>
+              </a:rPr>
+              <a:t>REFERENCES &amp; DATA SOURCES</a:t>
+            </a:r>
+          </a:p>
+        </p:txBody>
+      </p:sp>
+      <p:sp>
+        <p:nvSpPr>
+          <p:cNvPr id="5" name="TextBox 4"/>
+          <p:cNvSpPr txBox="1"/>
+          <p:nvPr/>
+        </p:nvSpPr>
+        <p:spPr>
+          <a:xfrm>
+            <a:off x="548640" y="640080"/>
+            <a:ext cx="10972800" cy="914400"/>
+          </a:xfrm>
+          <a:prstGeom prst="rect">
+            <a:avLst/>
+          </a:prstGeom>
+          <a:noFill/>
+        </p:spPr>
+        <p:txBody>
+          <a:bodyPr wrap="square">
+            <a:spAutoFit/>
+          </a:bodyPr>
+          <a:lstStyle/>
+          <a:p>
+            <a:pPr algn="l"/>
+            <a:r>
+              <a:rPr sz="3400" b="1" i="0">
+                <a:solidFill>
+                  <a:srgbClr val="FFFFFF"/>
+                </a:solidFill>
+                <a:latin typeface="Calibri"/>
+              </a:rPr>
+              <a:t>All data cited — sources and accuracy notes</a:t>
+            </a:r>
+          </a:p>
+        </p:txBody>
+      </p:sp>
+      <p:sp>
+        <p:nvSpPr>
+          <p:cNvPr id="6" name="Rectangle 5"/>
+          <p:cNvSpPr/>
+          <p:nvPr/>
+        </p:nvSpPr>
+        <p:spPr>
+          <a:xfrm>
+            <a:off x="548640" y="1481328"/>
+            <a:ext cx="1280160" cy="50292"/>
+          </a:xfrm>
+          <a:prstGeom prst="rect">
+            <a:avLst/>
+          </a:prstGeom>
+          <a:solidFill>
+            <a:srgbClr val="4D9EFF"/>
+          </a:solidFill>
+          <a:ln>
+            <a:noFill/>
+          </a:ln>
+        </p:spPr>
+        <p:style>
+          <a:lnRef idx="1">
+            <a:schemeClr val="accent1"/>
+          </a:lnRef>
+          <a:fillRef idx="3">
+            <a:schemeClr val="accent1"/>
+          </a:fillRef>
+          <a:effectRef idx="2">
+            <a:schemeClr val="accent1"/>
+          </a:effectRef>
+          <a:fontRef idx="minor">
+            <a:schemeClr val="lt1"/>
+          </a:fontRef>
+        </p:style>
+        <p:txBody>
+          <a:bodyPr rtlCol="0" anchor="ctr"/>
+          <a:lstStyle/>
+          <a:p>
+            <a:pPr algn="ctr"/>
+          </a:p>
+        </p:txBody>
+      </p:sp>
+      <p:sp>
+        <p:nvSpPr>
+          <p:cNvPr id="7" name="Rectangle 6"/>
+          <p:cNvSpPr/>
+          <p:nvPr/>
+        </p:nvSpPr>
+        <p:spPr>
+          <a:xfrm>
+            <a:off x="365760" y="1664208"/>
+            <a:ext cx="11430000" cy="329184"/>
+          </a:xfrm>
+          <a:prstGeom prst="rect">
+            <a:avLst/>
+          </a:prstGeom>
+          <a:solidFill>
+            <a:srgbClr val="0A1E34"/>
+          </a:solidFill>
+          <a:ln>
+            <a:noFill/>
+          </a:ln>
+        </p:spPr>
+        <p:style>
+          <a:lnRef idx="1">
+            <a:schemeClr val="accent1"/>
+          </a:lnRef>
+          <a:fillRef idx="3">
+            <a:schemeClr val="accent1"/>
+          </a:fillRef>
+          <a:effectRef idx="2">
+            <a:schemeClr val="accent1"/>
+          </a:effectRef>
+          <a:fontRef idx="minor">
+            <a:schemeClr val="lt1"/>
+          </a:fontRef>
+        </p:style>
+        <p:txBody>
+          <a:bodyPr rtlCol="0" anchor="ctr"/>
+          <a:lstStyle/>
+          <a:p>
+            <a:pPr algn="ctr"/>
+          </a:p>
+        </p:txBody>
+      </p:sp>
+      <p:sp>
+        <p:nvSpPr>
+          <p:cNvPr id="8" name="Rectangle 7"/>
+          <p:cNvSpPr/>
+          <p:nvPr/>
+        </p:nvSpPr>
+        <p:spPr>
+          <a:xfrm>
+            <a:off x="365760" y="1664208"/>
+            <a:ext cx="73152" cy="329184"/>
+          </a:xfrm>
+          <a:prstGeom prst="rect">
+            <a:avLst/>
+          </a:prstGeom>
+          <a:solidFill>
+            <a:srgbClr val="4D9EFF"/>
+          </a:solidFill>
+          <a:ln>
+            <a:noFill/>
+          </a:ln>
+        </p:spPr>
+        <p:style>
+          <a:lnRef idx="1">
+            <a:schemeClr val="accent1"/>
+          </a:lnRef>
+          <a:fillRef idx="3">
+            <a:schemeClr val="accent1"/>
+          </a:fillRef>
+          <a:effectRef idx="2">
+            <a:schemeClr val="accent1"/>
+          </a:effectRef>
+          <a:fontRef idx="minor">
+            <a:schemeClr val="lt1"/>
+          </a:fontRef>
+        </p:style>
+        <p:txBody>
+          <a:bodyPr rtlCol="0" anchor="ctr"/>
+          <a:lstStyle/>
+          <a:p>
+            <a:pPr algn="ctr"/>
+          </a:p>
+        </p:txBody>
+      </p:sp>
+      <p:sp>
+        <p:nvSpPr>
+          <p:cNvPr id="9" name="TextBox 8"/>
+          <p:cNvSpPr txBox="1"/>
+          <p:nvPr/>
+        </p:nvSpPr>
+        <p:spPr>
+          <a:xfrm>
+            <a:off x="548640" y="1700784"/>
+            <a:ext cx="10972800" cy="274320"/>
+          </a:xfrm>
+          <a:prstGeom prst="rect">
+            <a:avLst/>
+          </a:prstGeom>
+          <a:noFill/>
+        </p:spPr>
+        <p:txBody>
+          <a:bodyPr wrap="square">
+            <a:spAutoFit/>
+          </a:bodyPr>
+          <a:lstStyle/>
+          <a:p>
+            <a:pPr algn="l"/>
+            <a:r>
+              <a:rPr sz="1200" b="1" i="0">
+                <a:solidFill>
+                  <a:srgbClr val="4D9EFF"/>
+                </a:solidFill>
+                <a:latin typeface="Calibri"/>
+              </a:rPr>
+              <a:t>Vision Impairment Data</a:t>
+            </a:r>
+          </a:p>
+        </p:txBody>
+      </p:sp>
+      <p:sp>
+        <p:nvSpPr>
+          <p:cNvPr id="10" name="Rectangle 9"/>
+          <p:cNvSpPr/>
+          <p:nvPr/>
+        </p:nvSpPr>
+        <p:spPr>
+          <a:xfrm>
+            <a:off x="365760" y="2011680"/>
+            <a:ext cx="11430000" cy="493776"/>
+          </a:xfrm>
+          <a:prstGeom prst="rect">
+            <a:avLst/>
+          </a:prstGeom>
+          <a:solidFill>
+            <a:srgbClr val="0E2035"/>
+          </a:solidFill>
+          <a:ln>
+            <a:noFill/>
+          </a:ln>
+        </p:spPr>
+        <p:style>
+          <a:lnRef idx="1">
+            <a:schemeClr val="accent1"/>
+          </a:lnRef>
+          <a:fillRef idx="3">
+            <a:schemeClr val="accent1"/>
+          </a:fillRef>
+          <a:effectRef idx="2">
+            <a:schemeClr val="accent1"/>
+          </a:effectRef>
+          <a:fontRef idx="minor">
+            <a:schemeClr val="lt1"/>
+          </a:fontRef>
+        </p:style>
+        <p:txBody>
+          <a:bodyPr rtlCol="0" anchor="ctr"/>
+          <a:lstStyle/>
+          <a:p>
+            <a:pPr algn="ctr"/>
+          </a:p>
+        </p:txBody>
+      </p:sp>
+      <p:sp>
+        <p:nvSpPr>
+          <p:cNvPr id="11" name="TextBox 10"/>
+          <p:cNvSpPr txBox="1"/>
+          <p:nvPr/>
+        </p:nvSpPr>
+        <p:spPr>
+          <a:xfrm>
+            <a:off x="502920" y="2039112"/>
+            <a:ext cx="11064240" cy="228600"/>
+          </a:xfrm>
+          <a:prstGeom prst="rect">
+            <a:avLst/>
+          </a:prstGeom>
+          <a:noFill/>
+        </p:spPr>
+        <p:txBody>
+          <a:bodyPr wrap="square">
+            <a:spAutoFit/>
+          </a:bodyPr>
+          <a:lstStyle/>
+          <a:p>
+            <a:pPr algn="l"/>
+            <a:r>
+              <a:rPr sz="1050" b="1" i="0">
+                <a:solidFill>
+                  <a:srgbClr val="FFFFFF"/>
+                </a:solidFill>
+                <a:latin typeface="Calibri"/>
+              </a:rPr>
+              <a:t>[1] IAPB Vision Atlas 2023 — iapb.org/learn/iapb-vision-atlas</a:t>
+            </a:r>
+          </a:p>
+        </p:txBody>
+      </p:sp>
+      <p:sp>
+        <p:nvSpPr>
+          <p:cNvPr id="12" name="TextBox 11"/>
+          <p:cNvSpPr txBox="1"/>
+          <p:nvPr/>
+        </p:nvSpPr>
+        <p:spPr>
+          <a:xfrm>
+            <a:off x="502920" y="2258568"/>
+            <a:ext cx="11064240" cy="219456"/>
+          </a:xfrm>
+          <a:prstGeom prst="rect">
+            <a:avLst/>
+          </a:prstGeom>
+          <a:noFill/>
+        </p:spPr>
+        <p:txBody>
+          <a:bodyPr wrap="square">
+            <a:spAutoFit/>
+          </a:bodyPr>
+          <a:lstStyle/>
+          <a:p>
+            <a:pPr algn="l"/>
+            <a:r>
+              <a:rPr sz="950" b="0" i="1">
+                <a:solidFill>
+                  <a:srgbClr val="B2CCE8"/>
+                </a:solidFill>
+                <a:latin typeface="Calibri"/>
+              </a:rPr>
+              <a:t>India: 8.95M blind, 62.7M moderate-severe vision impairment = ~72M total. Used on Slides 2, 3.</a:t>
+            </a:r>
+          </a:p>
+        </p:txBody>
+      </p:sp>
+      <p:sp>
+        <p:nvSpPr>
+          <p:cNvPr id="13" name="Rectangle 12"/>
+          <p:cNvSpPr/>
+          <p:nvPr/>
+        </p:nvSpPr>
+        <p:spPr>
+          <a:xfrm>
+            <a:off x="365760" y="2523744"/>
+            <a:ext cx="11430000" cy="493776"/>
+          </a:xfrm>
+          <a:prstGeom prst="rect">
+            <a:avLst/>
+          </a:prstGeom>
+          <a:solidFill>
+            <a:srgbClr val="0E2035"/>
+          </a:solidFill>
+          <a:ln>
+            <a:noFill/>
+          </a:ln>
+        </p:spPr>
+        <p:style>
+          <a:lnRef idx="1">
+            <a:schemeClr val="accent1"/>
+          </a:lnRef>
+          <a:fillRef idx="3">
+            <a:schemeClr val="accent1"/>
+          </a:fillRef>
+          <a:effectRef idx="2">
+            <a:schemeClr val="accent1"/>
+          </a:effectRef>
+          <a:fontRef idx="minor">
+            <a:schemeClr val="lt1"/>
+          </a:fontRef>
+        </p:style>
+        <p:txBody>
+          <a:bodyPr rtlCol="0" anchor="ctr"/>
+          <a:lstStyle/>
+          <a:p>
+            <a:pPr algn="ctr"/>
+          </a:p>
+        </p:txBody>
+      </p:sp>
+      <p:sp>
+        <p:nvSpPr>
+          <p:cNvPr id="14" name="TextBox 13"/>
+          <p:cNvSpPr txBox="1"/>
+          <p:nvPr/>
+        </p:nvSpPr>
+        <p:spPr>
+          <a:xfrm>
+            <a:off x="502920" y="2551176"/>
+            <a:ext cx="11064240" cy="228600"/>
+          </a:xfrm>
+          <a:prstGeom prst="rect">
+            <a:avLst/>
+          </a:prstGeom>
+          <a:noFill/>
+        </p:spPr>
+        <p:txBody>
+          <a:bodyPr wrap="square">
+            <a:spAutoFit/>
+          </a:bodyPr>
+          <a:lstStyle/>
+          <a:p>
+            <a:pPr algn="l"/>
+            <a:r>
+              <a:rPr sz="1050" b="1" i="0">
+                <a:solidFill>
+                  <a:srgbClr val="FFFFFF"/>
+                </a:solidFill>
+                <a:latin typeface="Calibri"/>
+              </a:rPr>
+              <a:t>[2] WHO World Report on Vision, 2019 — WHO/NMH/PBD/19.1</a:t>
+            </a:r>
+          </a:p>
+        </p:txBody>
+      </p:sp>
+      <p:sp>
+        <p:nvSpPr>
+          <p:cNvPr id="15" name="TextBox 14"/>
+          <p:cNvSpPr txBox="1"/>
+          <p:nvPr/>
+        </p:nvSpPr>
+        <p:spPr>
+          <a:xfrm>
+            <a:off x="502920" y="2770632"/>
+            <a:ext cx="11064240" cy="219456"/>
+          </a:xfrm>
+          <a:prstGeom prst="rect">
+            <a:avLst/>
+          </a:prstGeom>
+          <a:noFill/>
+        </p:spPr>
+        <p:txBody>
+          <a:bodyPr wrap="square">
+            <a:spAutoFit/>
+          </a:bodyPr>
+          <a:lstStyle/>
+          <a:p>
+            <a:pPr algn="l"/>
+            <a:r>
+              <a:rPr sz="950" b="0" i="1">
+                <a:solidFill>
+                  <a:srgbClr val="B2CCE8"/>
+                </a:solidFill>
+                <a:latin typeface="Calibri"/>
+              </a:rPr>
+              <a:t>Global overview of vision impairment burden; India is the country with the highest number of blind people globally.</a:t>
+            </a:r>
+          </a:p>
+        </p:txBody>
+      </p:sp>
+      <p:sp>
+        <p:nvSpPr>
+          <p:cNvPr id="16" name="Rectangle 15"/>
+          <p:cNvSpPr/>
+          <p:nvPr/>
+        </p:nvSpPr>
+        <p:spPr>
+          <a:xfrm>
+            <a:off x="365760" y="3072384"/>
+            <a:ext cx="11430000" cy="329184"/>
+          </a:xfrm>
+          <a:prstGeom prst="rect">
+            <a:avLst/>
+          </a:prstGeom>
+          <a:solidFill>
+            <a:srgbClr val="0A1E34"/>
+          </a:solidFill>
+          <a:ln>
+            <a:noFill/>
+          </a:ln>
+        </p:spPr>
+        <p:style>
+          <a:lnRef idx="1">
+            <a:schemeClr val="accent1"/>
+          </a:lnRef>
+          <a:fillRef idx="3">
+            <a:schemeClr val="accent1"/>
+          </a:fillRef>
+          <a:effectRef idx="2">
+            <a:schemeClr val="accent1"/>
+          </a:effectRef>
+          <a:fontRef idx="minor">
+            <a:schemeClr val="lt1"/>
+          </a:fontRef>
+        </p:style>
+        <p:txBody>
+          <a:bodyPr rtlCol="0" anchor="ctr"/>
+          <a:lstStyle/>
+          <a:p>
+            <a:pPr algn="ctr"/>
+          </a:p>
+        </p:txBody>
+      </p:sp>
+      <p:sp>
+        <p:nvSpPr>
+          <p:cNvPr id="17" name="Rectangle 16"/>
+          <p:cNvSpPr/>
+          <p:nvPr/>
+        </p:nvSpPr>
+        <p:spPr>
+          <a:xfrm>
+            <a:off x="365760" y="3072384"/>
+            <a:ext cx="73152" cy="329184"/>
+          </a:xfrm>
+          <a:prstGeom prst="rect">
+            <a:avLst/>
+          </a:prstGeom>
+          <a:solidFill>
+            <a:srgbClr val="00BFA5"/>
+          </a:solidFill>
+          <a:ln>
+            <a:noFill/>
+          </a:ln>
+        </p:spPr>
+        <p:style>
+          <a:lnRef idx="1">
+            <a:schemeClr val="accent1"/>
+          </a:lnRef>
+          <a:fillRef idx="3">
+            <a:schemeClr val="accent1"/>
+          </a:fillRef>
+          <a:effectRef idx="2">
+            <a:schemeClr val="accent1"/>
+          </a:effectRef>
+          <a:fontRef idx="minor">
+            <a:schemeClr val="lt1"/>
+          </a:fontRef>
+        </p:style>
+        <p:txBody>
+          <a:bodyPr rtlCol="0" anchor="ctr"/>
+          <a:lstStyle/>
+          <a:p>
+            <a:pPr algn="ctr"/>
+          </a:p>
+        </p:txBody>
+      </p:sp>
+      <p:sp>
+        <p:nvSpPr>
+          <p:cNvPr id="18" name="TextBox 17"/>
+          <p:cNvSpPr txBox="1"/>
+          <p:nvPr/>
+        </p:nvSpPr>
+        <p:spPr>
+          <a:xfrm>
+            <a:off x="548640" y="3108960"/>
+            <a:ext cx="10972800" cy="274320"/>
+          </a:xfrm>
+          <a:prstGeom prst="rect">
+            <a:avLst/>
+          </a:prstGeom>
+          <a:noFill/>
+        </p:spPr>
+        <p:txBody>
+          <a:bodyPr wrap="square">
+            <a:spAutoFit/>
+          </a:bodyPr>
+          <a:lstStyle/>
+          <a:p>
+            <a:pPr algn="l"/>
+            <a:r>
+              <a:rPr sz="1200" b="1" i="0">
+                <a:solidFill>
+                  <a:srgbClr val="00BFA5"/>
+                </a:solidFill>
+                <a:latin typeface="Calibri"/>
+              </a:rPr>
+              <a:t>Ageing &amp; Senior Citizens</a:t>
+            </a:r>
+          </a:p>
+        </p:txBody>
+      </p:sp>
+      <p:sp>
+        <p:nvSpPr>
+          <p:cNvPr id="19" name="Rectangle 18"/>
+          <p:cNvSpPr/>
+          <p:nvPr/>
+        </p:nvSpPr>
+        <p:spPr>
+          <a:xfrm>
+            <a:off x="365760" y="3419856"/>
+            <a:ext cx="11430000" cy="493776"/>
+          </a:xfrm>
+          <a:prstGeom prst="rect">
+            <a:avLst/>
+          </a:prstGeom>
+          <a:solidFill>
+            <a:srgbClr val="0E2035"/>
+          </a:solidFill>
+          <a:ln>
+            <a:noFill/>
+          </a:ln>
+        </p:spPr>
+        <p:style>
+          <a:lnRef idx="1">
+            <a:schemeClr val="accent1"/>
+          </a:lnRef>
+          <a:fillRef idx="3">
+            <a:schemeClr val="accent1"/>
+          </a:fillRef>
+          <a:effectRef idx="2">
+            <a:schemeClr val="accent1"/>
+          </a:effectRef>
+          <a:fontRef idx="minor">
+            <a:schemeClr val="lt1"/>
+          </a:fontRef>
+        </p:style>
+        <p:txBody>
+          <a:bodyPr rtlCol="0" anchor="ctr"/>
+          <a:lstStyle/>
+          <a:p>
+            <a:pPr algn="ctr"/>
+          </a:p>
+        </p:txBody>
+      </p:sp>
+      <p:sp>
+        <p:nvSpPr>
+          <p:cNvPr id="20" name="TextBox 19"/>
+          <p:cNvSpPr txBox="1"/>
+          <p:nvPr/>
+        </p:nvSpPr>
+        <p:spPr>
+          <a:xfrm>
+            <a:off x="502920" y="3447288"/>
+            <a:ext cx="11064240" cy="228600"/>
+          </a:xfrm>
+          <a:prstGeom prst="rect">
+            <a:avLst/>
+          </a:prstGeom>
+          <a:noFill/>
+        </p:spPr>
+        <p:txBody>
+          <a:bodyPr wrap="square">
+            <a:spAutoFit/>
+          </a:bodyPr>
+          <a:lstStyle/>
+          <a:p>
+            <a:pPr algn="l"/>
+            <a:r>
+              <a:rPr sz="1050" b="1" i="0">
+                <a:solidFill>
+                  <a:srgbClr val="FFFFFF"/>
+                </a:solidFill>
+                <a:latin typeface="Calibri"/>
+              </a:rPr>
+              <a:t>[3] UN World Population Ageing 2023 — un.org/development/desa/pd</a:t>
+            </a:r>
+          </a:p>
+        </p:txBody>
+      </p:sp>
+      <p:sp>
+        <p:nvSpPr>
+          <p:cNvPr id="21" name="TextBox 20"/>
+          <p:cNvSpPr txBox="1"/>
+          <p:nvPr/>
+        </p:nvSpPr>
+        <p:spPr>
+          <a:xfrm>
+            <a:off x="502920" y="3666744"/>
+            <a:ext cx="11064240" cy="219456"/>
+          </a:xfrm>
+          <a:prstGeom prst="rect">
+            <a:avLst/>
+          </a:prstGeom>
+          <a:noFill/>
+        </p:spPr>
+        <p:txBody>
+          <a:bodyPr wrap="square">
+            <a:spAutoFit/>
+          </a:bodyPr>
+          <a:lstStyle/>
+          <a:p>
+            <a:pPr algn="l"/>
+            <a:r>
+              <a:rPr sz="950" b="0" i="1">
+                <a:solidFill>
+                  <a:srgbClr val="B2CCE8"/>
+                </a:solidFill>
+                <a:latin typeface="Calibri"/>
+              </a:rPr>
+              <a:t>India 60+ population: ~145M current (2023); projected 347M by 2050. Slide 3 uses current figure with projection noted.</a:t>
+            </a:r>
+          </a:p>
+        </p:txBody>
+      </p:sp>
+      <p:sp>
+        <p:nvSpPr>
+          <p:cNvPr id="22" name="Rectangle 21"/>
+          <p:cNvSpPr/>
+          <p:nvPr/>
+        </p:nvSpPr>
+        <p:spPr>
+          <a:xfrm>
+            <a:off x="365760" y="3931920"/>
+            <a:ext cx="11430000" cy="493776"/>
+          </a:xfrm>
+          <a:prstGeom prst="rect">
+            <a:avLst/>
+          </a:prstGeom>
+          <a:solidFill>
+            <a:srgbClr val="0E2035"/>
+          </a:solidFill>
+          <a:ln>
+            <a:noFill/>
+          </a:ln>
+        </p:spPr>
+        <p:style>
+          <a:lnRef idx="1">
+            <a:schemeClr val="accent1"/>
+          </a:lnRef>
+          <a:fillRef idx="3">
+            <a:schemeClr val="accent1"/>
+          </a:fillRef>
+          <a:effectRef idx="2">
+            <a:schemeClr val="accent1"/>
+          </a:effectRef>
+          <a:fontRef idx="minor">
+            <a:schemeClr val="lt1"/>
+          </a:fontRef>
+        </p:style>
+        <p:txBody>
+          <a:bodyPr rtlCol="0" anchor="ctr"/>
+          <a:lstStyle/>
+          <a:p>
+            <a:pPr algn="ctr"/>
+          </a:p>
+        </p:txBody>
+      </p:sp>
+      <p:sp>
+        <p:nvSpPr>
+          <p:cNvPr id="23" name="TextBox 22"/>
+          <p:cNvSpPr txBox="1"/>
+          <p:nvPr/>
+        </p:nvSpPr>
+        <p:spPr>
+          <a:xfrm>
+            <a:off x="502920" y="3959352"/>
+            <a:ext cx="11064240" cy="228600"/>
+          </a:xfrm>
+          <a:prstGeom prst="rect">
+            <a:avLst/>
+          </a:prstGeom>
+          <a:noFill/>
+        </p:spPr>
+        <p:txBody>
+          <a:bodyPr wrap="square">
+            <a:spAutoFit/>
+          </a:bodyPr>
+          <a:lstStyle/>
+          <a:p>
+            <a:pPr algn="l"/>
+            <a:r>
+              <a:rPr sz="1050" b="1" i="0">
+                <a:solidFill>
+                  <a:srgbClr val="FFFFFF"/>
+                </a:solidFill>
+                <a:latin typeface="Calibri"/>
+              </a:rPr>
+              <a:t>[4] India Ageing Report 2023 — MoSPI / UNFPA India</a:t>
+            </a:r>
+          </a:p>
+        </p:txBody>
+      </p:sp>
+      <p:sp>
+        <p:nvSpPr>
+          <p:cNvPr id="24" name="TextBox 23"/>
+          <p:cNvSpPr txBox="1"/>
+          <p:nvPr/>
+        </p:nvSpPr>
+        <p:spPr>
+          <a:xfrm>
+            <a:off x="502920" y="4178808"/>
+            <a:ext cx="11064240" cy="219456"/>
+          </a:xfrm>
+          <a:prstGeom prst="rect">
+            <a:avLst/>
+          </a:prstGeom>
+          <a:noFill/>
+        </p:spPr>
+        <p:txBody>
+          <a:bodyPr wrap="square">
+            <a:spAutoFit/>
+          </a:bodyPr>
+          <a:lstStyle/>
+          <a:p>
+            <a:pPr algn="l"/>
+            <a:r>
+              <a:rPr sz="950" b="0" i="1">
+                <a:solidFill>
+                  <a:srgbClr val="B2CCE8"/>
+                </a:solidFill>
+                <a:latin typeface="Calibri"/>
+              </a:rPr>
+              <a:t>Published by Ministry of Statistics &amp; Programme Implementation; confirms UN projections for India's elderly population trajectory.</a:t>
+            </a:r>
+          </a:p>
+        </p:txBody>
+      </p:sp>
+      <p:sp>
+        <p:nvSpPr>
+          <p:cNvPr id="25" name="Rectangle 24"/>
+          <p:cNvSpPr/>
+          <p:nvPr/>
+        </p:nvSpPr>
+        <p:spPr>
+          <a:xfrm>
+            <a:off x="365760" y="4480560"/>
+            <a:ext cx="11430000" cy="329184"/>
+          </a:xfrm>
+          <a:prstGeom prst="rect">
+            <a:avLst/>
+          </a:prstGeom>
+          <a:solidFill>
+            <a:srgbClr val="0A1E34"/>
+          </a:solidFill>
+          <a:ln>
+            <a:noFill/>
+          </a:ln>
+        </p:spPr>
+        <p:style>
+          <a:lnRef idx="1">
+            <a:schemeClr val="accent1"/>
+          </a:lnRef>
+          <a:fillRef idx="3">
+            <a:schemeClr val="accent1"/>
+          </a:fillRef>
+          <a:effectRef idx="2">
+            <a:schemeClr val="accent1"/>
+          </a:effectRef>
+          <a:fontRef idx="minor">
+            <a:schemeClr val="lt1"/>
+          </a:fontRef>
+        </p:style>
+        <p:txBody>
+          <a:bodyPr rtlCol="0" anchor="ctr"/>
+          <a:lstStyle/>
+          <a:p>
+            <a:pPr algn="ctr"/>
+          </a:p>
+        </p:txBody>
+      </p:sp>
+      <p:sp>
+        <p:nvSpPr>
+          <p:cNvPr id="26" name="Rectangle 25"/>
+          <p:cNvSpPr/>
+          <p:nvPr/>
+        </p:nvSpPr>
+        <p:spPr>
+          <a:xfrm>
+            <a:off x="365760" y="4480560"/>
+            <a:ext cx="73152" cy="329184"/>
+          </a:xfrm>
+          <a:prstGeom prst="rect">
+            <a:avLst/>
+          </a:prstGeom>
+          <a:solidFill>
+            <a:srgbClr val="FF6B35"/>
+          </a:solidFill>
+          <a:ln>
+            <a:noFill/>
+          </a:ln>
+        </p:spPr>
+        <p:style>
+          <a:lnRef idx="1">
+            <a:schemeClr val="accent1"/>
+          </a:lnRef>
+          <a:fillRef idx="3">
+            <a:schemeClr val="accent1"/>
+          </a:fillRef>
+          <a:effectRef idx="2">
+            <a:schemeClr val="accent1"/>
+          </a:effectRef>
+          <a:fontRef idx="minor">
+            <a:schemeClr val="lt1"/>
+          </a:fontRef>
+        </p:style>
+        <p:txBody>
+          <a:bodyPr rtlCol="0" anchor="ctr"/>
+          <a:lstStyle/>
+          <a:p>
+            <a:pPr algn="ctr"/>
+          </a:p>
+        </p:txBody>
+      </p:sp>
+      <p:sp>
+        <p:nvSpPr>
+          <p:cNvPr id="27" name="TextBox 26"/>
+          <p:cNvSpPr txBox="1"/>
+          <p:nvPr/>
+        </p:nvSpPr>
+        <p:spPr>
+          <a:xfrm>
+            <a:off x="548640" y="4517136"/>
+            <a:ext cx="10972800" cy="274320"/>
+          </a:xfrm>
+          <a:prstGeom prst="rect">
+            <a:avLst/>
+          </a:prstGeom>
+          <a:noFill/>
+        </p:spPr>
+        <p:txBody>
+          <a:bodyPr wrap="square">
+            <a:spAutoFit/>
+          </a:bodyPr>
+          <a:lstStyle/>
+          <a:p>
+            <a:pPr algn="l"/>
+            <a:r>
+              <a:rPr sz="1200" b="1" i="0">
+                <a:solidFill>
+                  <a:srgbClr val="FF6B35"/>
+                </a:solidFill>
+                <a:latin typeface="Calibri"/>
+              </a:rPr>
+              <a:t>Colour-Blindness</a:t>
+            </a:r>
+          </a:p>
+        </p:txBody>
+      </p:sp>
+      <p:sp>
+        <p:nvSpPr>
+          <p:cNvPr id="28" name="Rectangle 27"/>
+          <p:cNvSpPr/>
+          <p:nvPr/>
+        </p:nvSpPr>
+        <p:spPr>
+          <a:xfrm>
+            <a:off x="365760" y="4828032"/>
+            <a:ext cx="11430000" cy="493776"/>
+          </a:xfrm>
+          <a:prstGeom prst="rect">
+            <a:avLst/>
+          </a:prstGeom>
+          <a:solidFill>
+            <a:srgbClr val="0E2035"/>
+          </a:solidFill>
+          <a:ln>
+            <a:noFill/>
+          </a:ln>
+        </p:spPr>
+        <p:style>
+          <a:lnRef idx="1">
+            <a:schemeClr val="accent1"/>
+          </a:lnRef>
+          <a:fillRef idx="3">
+            <a:schemeClr val="accent1"/>
+          </a:fillRef>
+          <a:effectRef idx="2">
+            <a:schemeClr val="accent1"/>
+          </a:effectRef>
+          <a:fontRef idx="minor">
+            <a:schemeClr val="lt1"/>
+          </a:fontRef>
+        </p:style>
+        <p:txBody>
+          <a:bodyPr rtlCol="0" anchor="ctr"/>
+          <a:lstStyle/>
+          <a:p>
+            <a:pPr algn="ctr"/>
+          </a:p>
+        </p:txBody>
+      </p:sp>
+      <p:sp>
+        <p:nvSpPr>
+          <p:cNvPr id="29" name="TextBox 28"/>
+          <p:cNvSpPr txBox="1"/>
+          <p:nvPr/>
+        </p:nvSpPr>
+        <p:spPr>
+          <a:xfrm>
+            <a:off x="502920" y="4855464"/>
+            <a:ext cx="11064240" cy="228600"/>
+          </a:xfrm>
+          <a:prstGeom prst="rect">
+            <a:avLst/>
+          </a:prstGeom>
+          <a:noFill/>
+        </p:spPr>
+        <p:txBody>
+          <a:bodyPr wrap="square">
+            <a:spAutoFit/>
+          </a:bodyPr>
+          <a:lstStyle/>
+          <a:p>
+            <a:pPr algn="l"/>
+            <a:r>
+              <a:rPr sz="1050" b="1" i="0">
+                <a:solidFill>
+                  <a:srgbClr val="FFFFFF"/>
+                </a:solidFill>
+                <a:latin typeface="Calibri"/>
+              </a:rPr>
+              <a:t>[5] Colour Blind Awareness — colourblindawareness.org</a:t>
+            </a:r>
+          </a:p>
+        </p:txBody>
+      </p:sp>
+      <p:sp>
+        <p:nvSpPr>
+          <p:cNvPr id="30" name="TextBox 29"/>
+          <p:cNvSpPr txBox="1"/>
+          <p:nvPr/>
+        </p:nvSpPr>
+        <p:spPr>
+          <a:xfrm>
+            <a:off x="502920" y="5074920"/>
+            <a:ext cx="11064240" cy="219456"/>
+          </a:xfrm>
+          <a:prstGeom prst="rect">
+            <a:avLst/>
+          </a:prstGeom>
+          <a:noFill/>
+        </p:spPr>
+        <p:txBody>
+          <a:bodyPr wrap="square">
+            <a:spAutoFit/>
+          </a:bodyPr>
+          <a:lstStyle/>
+          <a:p>
+            <a:pPr algn="l"/>
+            <a:r>
+              <a:rPr sz="950" b="0" i="1">
+                <a:solidFill>
+                  <a:srgbClr val="B2CCE8"/>
+                </a:solidFill>
+                <a:latin typeface="Calibri"/>
+              </a:rPr>
+              <a:t>~300M people globally are colour-blind; ~8% of males and 0.5% of females affected (all types combined). India ≈ 60M.</a:t>
+            </a:r>
+          </a:p>
+        </p:txBody>
+      </p:sp>
+      <p:sp>
+        <p:nvSpPr>
+          <p:cNvPr id="31" name="Rectangle 30"/>
+          <p:cNvSpPr/>
+          <p:nvPr/>
+        </p:nvSpPr>
+        <p:spPr>
+          <a:xfrm>
+            <a:off x="365760" y="5340096"/>
+            <a:ext cx="11430000" cy="493776"/>
+          </a:xfrm>
+          <a:prstGeom prst="rect">
+            <a:avLst/>
+          </a:prstGeom>
+          <a:solidFill>
+            <a:srgbClr val="0E2035"/>
+          </a:solidFill>
+          <a:ln>
+            <a:noFill/>
+          </a:ln>
+        </p:spPr>
+        <p:style>
+          <a:lnRef idx="1">
+            <a:schemeClr val="accent1"/>
+          </a:lnRef>
+          <a:fillRef idx="3">
+            <a:schemeClr val="accent1"/>
+          </a:fillRef>
+          <a:effectRef idx="2">
+            <a:schemeClr val="accent1"/>
+          </a:effectRef>
+          <a:fontRef idx="minor">
+            <a:schemeClr val="lt1"/>
+          </a:fontRef>
+        </p:style>
+        <p:txBody>
+          <a:bodyPr rtlCol="0" anchor="ctr"/>
+          <a:lstStyle/>
+          <a:p>
+            <a:pPr algn="ctr"/>
+          </a:p>
+        </p:txBody>
+      </p:sp>
+      <p:sp>
+        <p:nvSpPr>
+          <p:cNvPr id="32" name="TextBox 31"/>
+          <p:cNvSpPr txBox="1"/>
+          <p:nvPr/>
+        </p:nvSpPr>
+        <p:spPr>
+          <a:xfrm>
+            <a:off x="502920" y="5367528"/>
+            <a:ext cx="11064240" cy="228600"/>
+          </a:xfrm>
+          <a:prstGeom prst="rect">
+            <a:avLst/>
+          </a:prstGeom>
+          <a:noFill/>
+        </p:spPr>
+        <p:txBody>
+          <a:bodyPr wrap="square">
+            <a:spAutoFit/>
+          </a:bodyPr>
+          <a:lstStyle/>
+          <a:p>
+            <a:pPr algn="l"/>
+            <a:r>
+              <a:rPr sz="1050" b="1" i="0">
+                <a:solidFill>
+                  <a:srgbClr val="FFFFFF"/>
+                </a:solidFill>
+                <a:latin typeface="Calibri"/>
+              </a:rPr>
+              <a:t>[6] Deeb, S.S. (2004). The molecular basis of variation in human color vision. Clinical Genetics, 67(5), 369–377.</a:t>
+            </a:r>
+          </a:p>
+        </p:txBody>
+      </p:sp>
+      <p:sp>
+        <p:nvSpPr>
+          <p:cNvPr id="33" name="TextBox 32"/>
+          <p:cNvSpPr txBox="1"/>
+          <p:nvPr/>
+        </p:nvSpPr>
+        <p:spPr>
+          <a:xfrm>
+            <a:off x="502920" y="5586984"/>
+            <a:ext cx="11064240" cy="219456"/>
+          </a:xfrm>
+          <a:prstGeom prst="rect">
+            <a:avLst/>
+          </a:prstGeom>
+          <a:noFill/>
+        </p:spPr>
+        <p:txBody>
+          <a:bodyPr wrap="square">
+            <a:spAutoFit/>
+          </a:bodyPr>
+          <a:lstStyle/>
+          <a:p>
+            <a:pPr algn="l"/>
+            <a:r>
+              <a:rPr sz="950" b="0" i="1">
+                <a:solidFill>
+                  <a:srgbClr val="B2CCE8"/>
+                </a:solidFill>
+                <a:latin typeface="Calibri"/>
+              </a:rPr>
+              <a:t>Peer-reviewed basis for deuteranopia (~4.63% males) and protanopia (~1.01% males) prevalence figures.</a:t>
+            </a:r>
+          </a:p>
+        </p:txBody>
+      </p:sp>
+      <p:sp>
+        <p:nvSpPr>
+          <p:cNvPr id="34" name="Rectangle 33"/>
+          <p:cNvSpPr/>
+          <p:nvPr/>
+        </p:nvSpPr>
+        <p:spPr>
+          <a:xfrm>
+            <a:off x="365760" y="5888736"/>
+            <a:ext cx="11430000" cy="329184"/>
+          </a:xfrm>
+          <a:prstGeom prst="rect">
+            <a:avLst/>
+          </a:prstGeom>
+          <a:solidFill>
+            <a:srgbClr val="0A1E34"/>
+          </a:solidFill>
+          <a:ln>
+            <a:noFill/>
+          </a:ln>
+        </p:spPr>
+        <p:style>
+          <a:lnRef idx="1">
+            <a:schemeClr val="accent1"/>
+          </a:lnRef>
+          <a:fillRef idx="3">
+            <a:schemeClr val="accent1"/>
+          </a:fillRef>
+          <a:effectRef idx="2">
+            <a:schemeClr val="accent1"/>
+          </a:effectRef>
+          <a:fontRef idx="minor">
+            <a:schemeClr val="lt1"/>
+          </a:fontRef>
+        </p:style>
+        <p:txBody>
+          <a:bodyPr rtlCol="0" anchor="ctr"/>
+          <a:lstStyle/>
+          <a:p>
+            <a:pPr algn="ctr"/>
+          </a:p>
+        </p:txBody>
+      </p:sp>
+      <p:sp>
+        <p:nvSpPr>
+          <p:cNvPr id="35" name="Rectangle 34"/>
+          <p:cNvSpPr/>
+          <p:nvPr/>
+        </p:nvSpPr>
+        <p:spPr>
+          <a:xfrm>
+            <a:off x="365760" y="5888736"/>
+            <a:ext cx="73152" cy="329184"/>
+          </a:xfrm>
+          <a:prstGeom prst="rect">
+            <a:avLst/>
+          </a:prstGeom>
+          <a:solidFill>
+            <a:srgbClr val="FFC107"/>
+          </a:solidFill>
+          <a:ln>
+            <a:noFill/>
+          </a:ln>
+        </p:spPr>
+        <p:style>
+          <a:lnRef idx="1">
+            <a:schemeClr val="accent1"/>
+          </a:lnRef>
+          <a:fillRef idx="3">
+            <a:schemeClr val="accent1"/>
+          </a:fillRef>
+          <a:effectRef idx="2">
+            <a:schemeClr val="accent1"/>
+          </a:effectRef>
+          <a:fontRef idx="minor">
+            <a:schemeClr val="lt1"/>
+          </a:fontRef>
+        </p:style>
+        <p:txBody>
+          <a:bodyPr rtlCol="0" anchor="ctr"/>
+          <a:lstStyle/>
+          <a:p>
+            <a:pPr algn="ctr"/>
+          </a:p>
+        </p:txBody>
+      </p:sp>
+      <p:sp>
+        <p:nvSpPr>
+          <p:cNvPr id="36" name="TextBox 35"/>
+          <p:cNvSpPr txBox="1"/>
+          <p:nvPr/>
+        </p:nvSpPr>
+        <p:spPr>
+          <a:xfrm>
+            <a:off x="548640" y="5925312"/>
+            <a:ext cx="10972800" cy="274320"/>
+          </a:xfrm>
+          <a:prstGeom prst="rect">
+            <a:avLst/>
+          </a:prstGeom>
+          <a:noFill/>
+        </p:spPr>
+        <p:txBody>
+          <a:bodyPr wrap="square">
+            <a:spAutoFit/>
+          </a:bodyPr>
+          <a:lstStyle/>
+          <a:p>
+            <a:pPr algn="l"/>
+            <a:r>
+              <a:rPr sz="1200" b="1" i="0">
+                <a:solidFill>
+                  <a:srgbClr val="FFC107"/>
+                </a:solidFill>
+                <a:latin typeface="Calibri"/>
+              </a:rPr>
+              <a:t>Literacy &amp; Rural Access</a:t>
+            </a:r>
+          </a:p>
+        </p:txBody>
+      </p:sp>
+      <p:sp>
+        <p:nvSpPr>
+          <p:cNvPr id="37" name="Rectangle 36"/>
+          <p:cNvSpPr/>
+          <p:nvPr/>
+        </p:nvSpPr>
+        <p:spPr>
+          <a:xfrm>
+            <a:off x="365760" y="6236208"/>
+            <a:ext cx="11430000" cy="493776"/>
+          </a:xfrm>
+          <a:prstGeom prst="rect">
+            <a:avLst/>
+          </a:prstGeom>
+          <a:solidFill>
+            <a:srgbClr val="0E2035"/>
+          </a:solidFill>
+          <a:ln>
+            <a:noFill/>
+          </a:ln>
+        </p:spPr>
+        <p:style>
+          <a:lnRef idx="1">
+            <a:schemeClr val="accent1"/>
+          </a:lnRef>
+          <a:fillRef idx="3">
+            <a:schemeClr val="accent1"/>
+          </a:fillRef>
+          <a:effectRef idx="2">
+            <a:schemeClr val="accent1"/>
+          </a:effectRef>
+          <a:fontRef idx="minor">
+            <a:schemeClr val="lt1"/>
+          </a:fontRef>
+        </p:style>
+        <p:txBody>
+          <a:bodyPr rtlCol="0" anchor="ctr"/>
+          <a:lstStyle/>
+          <a:p>
+            <a:pPr algn="ctr"/>
+          </a:p>
+        </p:txBody>
+      </p:sp>
+      <p:sp>
+        <p:nvSpPr>
+          <p:cNvPr id="38" name="TextBox 37"/>
+          <p:cNvSpPr txBox="1"/>
+          <p:nvPr/>
+        </p:nvSpPr>
+        <p:spPr>
+          <a:xfrm>
+            <a:off x="502920" y="6263640"/>
+            <a:ext cx="11064240" cy="228600"/>
+          </a:xfrm>
+          <a:prstGeom prst="rect">
+            <a:avLst/>
+          </a:prstGeom>
+          <a:noFill/>
+        </p:spPr>
+        <p:txBody>
+          <a:bodyPr wrap="square">
+            <a:spAutoFit/>
+          </a:bodyPr>
+          <a:lstStyle/>
+          <a:p>
+            <a:pPr algn="l"/>
+            <a:r>
+              <a:rPr sz="1050" b="1" i="0">
+                <a:solidFill>
+                  <a:srgbClr val="FFFFFF"/>
+                </a:solidFill>
+                <a:latin typeface="Calibri"/>
+              </a:rPr>
+              <a:t>[7] Census of India 2011 — censusindia.gov.in</a:t>
+            </a:r>
+          </a:p>
+        </p:txBody>
+      </p:sp>
+      <p:sp>
+        <p:nvSpPr>
+          <p:cNvPr id="39" name="TextBox 38"/>
+          <p:cNvSpPr txBox="1"/>
+          <p:nvPr/>
+        </p:nvSpPr>
+        <p:spPr>
+          <a:xfrm>
+            <a:off x="502920" y="6483096"/>
+            <a:ext cx="11064240" cy="219456"/>
+          </a:xfrm>
+          <a:prstGeom prst="rect">
+            <a:avLst/>
+          </a:prstGeom>
+          <a:noFill/>
+        </p:spPr>
+        <p:txBody>
+          <a:bodyPr wrap="square">
+            <a:spAutoFit/>
+          </a:bodyPr>
+          <a:lstStyle/>
+          <a:p>
+            <a:pPr algn="l"/>
+            <a:r>
+              <a:rPr sz="950" b="0" i="1">
+                <a:solidFill>
+                  <a:srgbClr val="B2CCE8"/>
+                </a:solidFill>
+                <a:latin typeface="Calibri"/>
+              </a:rPr>
+              <a:t>Literacy rate 74.04%. Applied to 2023 population (~1.43B) gives ~372M with limited literacy. Used on Slides 2, 3.</a:t>
+            </a:r>
+          </a:p>
+        </p:txBody>
+      </p:sp>
+      <p:sp>
+        <p:nvSpPr>
+          <p:cNvPr id="40" name="Rectangle 39"/>
+          <p:cNvSpPr/>
+          <p:nvPr/>
+        </p:nvSpPr>
+        <p:spPr>
+          <a:xfrm>
+            <a:off x="365760" y="6748272"/>
+            <a:ext cx="11430000" cy="493776"/>
+          </a:xfrm>
+          <a:prstGeom prst="rect">
+            <a:avLst/>
+          </a:prstGeom>
+          <a:solidFill>
+            <a:srgbClr val="0E2035"/>
+          </a:solidFill>
+          <a:ln>
+            <a:noFill/>
+          </a:ln>
+        </p:spPr>
+        <p:style>
+          <a:lnRef idx="1">
+            <a:schemeClr val="accent1"/>
+          </a:lnRef>
+          <a:fillRef idx="3">
+            <a:schemeClr val="accent1"/>
+          </a:fillRef>
+          <a:effectRef idx="2">
+            <a:schemeClr val="accent1"/>
+          </a:effectRef>
+          <a:fontRef idx="minor">
+            <a:schemeClr val="lt1"/>
+          </a:fontRef>
+        </p:style>
+        <p:txBody>
+          <a:bodyPr rtlCol="0" anchor="ctr"/>
+          <a:lstStyle/>
+          <a:p>
+            <a:pPr algn="ctr"/>
+          </a:p>
+        </p:txBody>
+      </p:sp>
+      <p:sp>
+        <p:nvSpPr>
+          <p:cNvPr id="41" name="TextBox 40"/>
+          <p:cNvSpPr txBox="1"/>
+          <p:nvPr/>
+        </p:nvSpPr>
+        <p:spPr>
+          <a:xfrm>
+            <a:off x="502920" y="6775704"/>
+            <a:ext cx="11064240" cy="228600"/>
+          </a:xfrm>
+          <a:prstGeom prst="rect">
+            <a:avLst/>
+          </a:prstGeom>
+          <a:noFill/>
+        </p:spPr>
+        <p:txBody>
+          <a:bodyPr wrap="square">
+            <a:spAutoFit/>
+          </a:bodyPr>
+          <a:lstStyle/>
+          <a:p>
+            <a:pPr algn="l"/>
+            <a:r>
+              <a:rPr sz="1050" b="1" i="0">
+                <a:solidFill>
+                  <a:srgbClr val="FFFFFF"/>
+                </a:solidFill>
+                <a:latin typeface="Calibri"/>
+              </a:rPr>
+              <a:t>[8] National Literacy Mission, Govt. of India — nlm.nic.in</a:t>
+            </a:r>
+          </a:p>
+        </p:txBody>
+      </p:sp>
+      <p:sp>
+        <p:nvSpPr>
+          <p:cNvPr id="42" name="TextBox 41"/>
+          <p:cNvSpPr txBox="1"/>
+          <p:nvPr/>
+        </p:nvSpPr>
+        <p:spPr>
+          <a:xfrm>
+            <a:off x="502920" y="6995160"/>
+            <a:ext cx="11064240" cy="219456"/>
+          </a:xfrm>
+          <a:prstGeom prst="rect">
+            <a:avLst/>
+          </a:prstGeom>
+          <a:noFill/>
+        </p:spPr>
+        <p:txBody>
+          <a:bodyPr wrap="square">
+            <a:spAutoFit/>
+          </a:bodyPr>
+          <a:lstStyle/>
+          <a:p>
+            <a:pPr algn="l"/>
+            <a:r>
+              <a:rPr sz="950" b="0" i="1">
+                <a:solidFill>
+                  <a:srgbClr val="B2CCE8"/>
+                </a:solidFill>
+                <a:latin typeface="Calibri"/>
+              </a:rPr>
+              <a:t>Functional literacy definition and adult literacy programme data.</a:t>
+            </a:r>
+          </a:p>
+        </p:txBody>
+      </p:sp>
+      <p:sp>
+        <p:nvSpPr>
+          <p:cNvPr id="43" name="Rectangle 42"/>
+          <p:cNvSpPr/>
+          <p:nvPr/>
+        </p:nvSpPr>
+        <p:spPr>
+          <a:xfrm>
+            <a:off x="365760" y="7296912"/>
+            <a:ext cx="11430000" cy="329184"/>
+          </a:xfrm>
+          <a:prstGeom prst="rect">
+            <a:avLst/>
+          </a:prstGeom>
+          <a:solidFill>
+            <a:srgbClr val="0A1E34"/>
+          </a:solidFill>
+          <a:ln>
+            <a:noFill/>
+          </a:ln>
+        </p:spPr>
+        <p:style>
+          <a:lnRef idx="1">
+            <a:schemeClr val="accent1"/>
+          </a:lnRef>
+          <a:fillRef idx="3">
+            <a:schemeClr val="accent1"/>
+          </a:fillRef>
+          <a:effectRef idx="2">
+            <a:schemeClr val="accent1"/>
+          </a:effectRef>
+          <a:fontRef idx="minor">
+            <a:schemeClr val="lt1"/>
+          </a:fontRef>
+        </p:style>
+        <p:txBody>
+          <a:bodyPr rtlCol="0" anchor="ctr"/>
+          <a:lstStyle/>
+          <a:p>
+            <a:pPr algn="ctr"/>
+          </a:p>
+        </p:txBody>
+      </p:sp>
+      <p:sp>
+        <p:nvSpPr>
+          <p:cNvPr id="44" name="Rectangle 43"/>
+          <p:cNvSpPr/>
+          <p:nvPr/>
+        </p:nvSpPr>
+        <p:spPr>
+          <a:xfrm>
+            <a:off x="365760" y="7296912"/>
+            <a:ext cx="73152" cy="329184"/>
+          </a:xfrm>
+          <a:prstGeom prst="rect">
+            <a:avLst/>
+          </a:prstGeom>
+          <a:solidFill>
+            <a:srgbClr val="AB47BC"/>
+          </a:solidFill>
+          <a:ln>
+            <a:noFill/>
+          </a:ln>
+        </p:spPr>
+        <p:style>
+          <a:lnRef idx="1">
+            <a:schemeClr val="accent1"/>
+          </a:lnRef>
+          <a:fillRef idx="3">
+            <a:schemeClr val="accent1"/>
+          </a:fillRef>
+          <a:effectRef idx="2">
+            <a:schemeClr val="accent1"/>
+          </a:effectRef>
+          <a:fontRef idx="minor">
+            <a:schemeClr val="lt1"/>
+          </a:fontRef>
+        </p:style>
+        <p:txBody>
+          <a:bodyPr rtlCol="0" anchor="ctr"/>
+          <a:lstStyle/>
+          <a:p>
+            <a:pPr algn="ctr"/>
+          </a:p>
+        </p:txBody>
+      </p:sp>
+      <p:sp>
+        <p:nvSpPr>
+          <p:cNvPr id="45" name="TextBox 44"/>
+          <p:cNvSpPr txBox="1"/>
+          <p:nvPr/>
+        </p:nvSpPr>
+        <p:spPr>
+          <a:xfrm>
+            <a:off x="548640" y="7333488"/>
+            <a:ext cx="10972800" cy="274320"/>
+          </a:xfrm>
+          <a:prstGeom prst="rect">
+            <a:avLst/>
+          </a:prstGeom>
+          <a:noFill/>
+        </p:spPr>
+        <p:txBody>
+          <a:bodyPr wrap="square">
+            <a:spAutoFit/>
+          </a:bodyPr>
+          <a:lstStyle/>
+          <a:p>
+            <a:pPr algn="l"/>
+            <a:r>
+              <a:rPr sz="1200" b="1" i="0">
+                <a:solidFill>
+                  <a:srgbClr val="AB47BC"/>
+                </a:solidFill>
+                <a:latin typeface="Calibri"/>
+              </a:rPr>
+              <a:t>Accessibility Standards</a:t>
+            </a:r>
+          </a:p>
+        </p:txBody>
+      </p:sp>
+      <p:sp>
+        <p:nvSpPr>
+          <p:cNvPr id="46" name="Rectangle 45"/>
+          <p:cNvSpPr/>
+          <p:nvPr/>
+        </p:nvSpPr>
+        <p:spPr>
+          <a:xfrm>
+            <a:off x="365760" y="7644384"/>
+            <a:ext cx="11430000" cy="493776"/>
+          </a:xfrm>
+          <a:prstGeom prst="rect">
+            <a:avLst/>
+          </a:prstGeom>
+          <a:solidFill>
+            <a:srgbClr val="0E2035"/>
+          </a:solidFill>
+          <a:ln>
+            <a:noFill/>
+          </a:ln>
+        </p:spPr>
+        <p:style>
+          <a:lnRef idx="1">
+            <a:schemeClr val="accent1"/>
+          </a:lnRef>
+          <a:fillRef idx="3">
+            <a:schemeClr val="accent1"/>
+          </a:fillRef>
+          <a:effectRef idx="2">
+            <a:schemeClr val="accent1"/>
+          </a:effectRef>
+          <a:fontRef idx="minor">
+            <a:schemeClr val="lt1"/>
+          </a:fontRef>
+        </p:style>
+        <p:txBody>
+          <a:bodyPr rtlCol="0" anchor="ctr"/>
+          <a:lstStyle/>
+          <a:p>
+            <a:pPr algn="ctr"/>
+          </a:p>
+        </p:txBody>
+      </p:sp>
+      <p:sp>
+        <p:nvSpPr>
+          <p:cNvPr id="47" name="TextBox 46"/>
+          <p:cNvSpPr txBox="1"/>
+          <p:nvPr/>
+        </p:nvSpPr>
+        <p:spPr>
+          <a:xfrm>
+            <a:off x="502920" y="7671816"/>
+            <a:ext cx="11064240" cy="228600"/>
+          </a:xfrm>
+          <a:prstGeom prst="rect">
+            <a:avLst/>
+          </a:prstGeom>
+          <a:noFill/>
+        </p:spPr>
+        <p:txBody>
+          <a:bodyPr wrap="square">
+            <a:spAutoFit/>
+          </a:bodyPr>
+          <a:lstStyle/>
+          <a:p>
+            <a:pPr algn="l"/>
+            <a:r>
+              <a:rPr sz="1050" b="1" i="0">
+                <a:solidFill>
+                  <a:srgbClr val="FFFFFF"/>
+                </a:solidFill>
+                <a:latin typeface="Calibri"/>
+              </a:rPr>
+              <a:t>[9] W3C WCAG 2.1 Guidelines — w3.org/TR/WCAG21</a:t>
+            </a:r>
+          </a:p>
+        </p:txBody>
+      </p:sp>
+      <p:sp>
+        <p:nvSpPr>
+          <p:cNvPr id="48" name="TextBox 47"/>
+          <p:cNvSpPr txBox="1"/>
+          <p:nvPr/>
+        </p:nvSpPr>
+        <p:spPr>
+          <a:xfrm>
+            <a:off x="502920" y="7891272"/>
+            <a:ext cx="11064240" cy="219456"/>
+          </a:xfrm>
+          <a:prstGeom prst="rect">
+            <a:avLst/>
+          </a:prstGeom>
+          <a:noFill/>
+        </p:spPr>
+        <p:txBody>
+          <a:bodyPr wrap="square">
+            <a:spAutoFit/>
+          </a:bodyPr>
+          <a:lstStyle/>
+          <a:p>
+            <a:pPr algn="l"/>
+            <a:r>
+              <a:rPr sz="950" b="0" i="1">
+                <a:solidFill>
+                  <a:srgbClr val="B2CCE8"/>
+                </a:solidFill>
+                <a:latin typeface="Calibri"/>
+              </a:rPr>
+              <a:t>SC 1.4.3: AA contrast 4.5:1 normal text. SC 1.4.6: AAA contrast 7:1. SC 1.4.4: text resizable to 200%. Slides 7, 8.</a:t>
+            </a:r>
+          </a:p>
+        </p:txBody>
+      </p:sp>
+      <p:sp>
+        <p:nvSpPr>
+          <p:cNvPr id="49" name="Rectangle 48"/>
+          <p:cNvSpPr/>
+          <p:nvPr/>
+        </p:nvSpPr>
+        <p:spPr>
+          <a:xfrm>
+            <a:off x="365760" y="8156448"/>
+            <a:ext cx="11430000" cy="493776"/>
+          </a:xfrm>
+          <a:prstGeom prst="rect">
+            <a:avLst/>
+          </a:prstGeom>
+          <a:solidFill>
+            <a:srgbClr val="0E2035"/>
+          </a:solidFill>
+          <a:ln>
+            <a:noFill/>
+          </a:ln>
+        </p:spPr>
+        <p:style>
+          <a:lnRef idx="1">
+            <a:schemeClr val="accent1"/>
+          </a:lnRef>
+          <a:fillRef idx="3">
+            <a:schemeClr val="accent1"/>
+          </a:fillRef>
+          <a:effectRef idx="2">
+            <a:schemeClr val="accent1"/>
+          </a:effectRef>
+          <a:fontRef idx="minor">
+            <a:schemeClr val="lt1"/>
+          </a:fontRef>
+        </p:style>
+        <p:txBody>
+          <a:bodyPr rtlCol="0" anchor="ctr"/>
+          <a:lstStyle/>
+          <a:p>
+            <a:pPr algn="ctr"/>
+          </a:p>
+        </p:txBody>
+      </p:sp>
+      <p:sp>
+        <p:nvSpPr>
+          <p:cNvPr id="50" name="TextBox 49"/>
+          <p:cNvSpPr txBox="1"/>
+          <p:nvPr/>
+        </p:nvSpPr>
+        <p:spPr>
+          <a:xfrm>
+            <a:off x="502920" y="8183880"/>
+            <a:ext cx="11064240" cy="228600"/>
+          </a:xfrm>
+          <a:prstGeom prst="rect">
+            <a:avLst/>
+          </a:prstGeom>
+          <a:noFill/>
+        </p:spPr>
+        <p:txBody>
+          <a:bodyPr wrap="square">
+            <a:spAutoFit/>
+          </a:bodyPr>
+          <a:lstStyle/>
+          <a:p>
+            <a:pPr algn="l"/>
+            <a:r>
+              <a:rPr sz="1050" b="1" i="0">
+                <a:solidFill>
+                  <a:srgbClr val="FFFFFF"/>
+                </a:solidFill>
+                <a:latin typeface="Calibri"/>
+              </a:rPr>
+              <a:t>[10] WebAIM Contrast Checker — webaim.org/resources/contrastchecker</a:t>
+            </a:r>
+          </a:p>
+        </p:txBody>
+      </p:sp>
+      <p:sp>
+        <p:nvSpPr>
+          <p:cNvPr id="51" name="TextBox 50"/>
+          <p:cNvSpPr txBox="1"/>
+          <p:nvPr/>
+        </p:nvSpPr>
+        <p:spPr>
+          <a:xfrm>
+            <a:off x="502920" y="8403336"/>
+            <a:ext cx="11064240" cy="219456"/>
+          </a:xfrm>
+          <a:prstGeom prst="rect">
+            <a:avLst/>
+          </a:prstGeom>
+          <a:noFill/>
+        </p:spPr>
+        <p:txBody>
+          <a:bodyPr wrap="square">
+            <a:spAutoFit/>
+          </a:bodyPr>
+          <a:lstStyle/>
+          <a:p>
+            <a:pPr algn="l"/>
+            <a:r>
+              <a:rPr sz="950" b="0" i="1">
+                <a:solidFill>
+                  <a:srgbClr val="B2CCE8"/>
+                </a:solidFill>
+                <a:latin typeface="Calibri"/>
+              </a:rPr>
+              <a:t>Verified contrast ratios: White #FFF on Navy #081320 = 18.7:1 (AAA). Amber #FFC107 on Navy = 11.5:1 (AAA).</a:t>
+            </a:r>
+          </a:p>
+        </p:txBody>
+      </p:sp>
+      <p:sp>
+        <p:nvSpPr>
+          <p:cNvPr id="52" name="Rectangle 51"/>
+          <p:cNvSpPr/>
+          <p:nvPr/>
+        </p:nvSpPr>
+        <p:spPr>
+          <a:xfrm>
+            <a:off x="365760" y="8668512"/>
+            <a:ext cx="11430000" cy="493776"/>
+          </a:xfrm>
+          <a:prstGeom prst="rect">
+            <a:avLst/>
+          </a:prstGeom>
+          <a:solidFill>
+            <a:srgbClr val="0E2035"/>
+          </a:solidFill>
+          <a:ln>
+            <a:noFill/>
+          </a:ln>
+        </p:spPr>
+        <p:style>
+          <a:lnRef idx="1">
+            <a:schemeClr val="accent1"/>
+          </a:lnRef>
+          <a:fillRef idx="3">
+            <a:schemeClr val="accent1"/>
+          </a:fillRef>
+          <a:effectRef idx="2">
+            <a:schemeClr val="accent1"/>
+          </a:effectRef>
+          <a:fontRef idx="minor">
+            <a:schemeClr val="lt1"/>
+          </a:fontRef>
+        </p:style>
+        <p:txBody>
+          <a:bodyPr rtlCol="0" anchor="ctr"/>
+          <a:lstStyle/>
+          <a:p>
+            <a:pPr algn="ctr"/>
+          </a:p>
+        </p:txBody>
+      </p:sp>
+      <p:sp>
+        <p:nvSpPr>
+          <p:cNvPr id="53" name="TextBox 52"/>
+          <p:cNvSpPr txBox="1"/>
+          <p:nvPr/>
+        </p:nvSpPr>
+        <p:spPr>
+          <a:xfrm>
+            <a:off x="502920" y="8695944"/>
+            <a:ext cx="11064240" cy="228600"/>
+          </a:xfrm>
+          <a:prstGeom prst="rect">
+            <a:avLst/>
+          </a:prstGeom>
+          <a:noFill/>
+        </p:spPr>
+        <p:txBody>
+          <a:bodyPr wrap="square">
+            <a:spAutoFit/>
+          </a:bodyPr>
+          <a:lstStyle/>
+          <a:p>
+            <a:pPr algn="l"/>
+            <a:r>
+              <a:rPr sz="1050" b="1" i="0">
+                <a:solidFill>
+                  <a:srgbClr val="FFFFFF"/>
+                </a:solidFill>
+                <a:latin typeface="Calibri"/>
+              </a:rPr>
+              <a:t>[11] Material Design Accessibility — m3.material.io/foundations/accessible-design</a:t>
+            </a:r>
+          </a:p>
+        </p:txBody>
+      </p:sp>
+      <p:sp>
+        <p:nvSpPr>
+          <p:cNvPr id="54" name="TextBox 53"/>
+          <p:cNvSpPr txBox="1"/>
+          <p:nvPr/>
+        </p:nvSpPr>
+        <p:spPr>
+          <a:xfrm>
+            <a:off x="502920" y="8915400"/>
+            <a:ext cx="11064240" cy="219456"/>
+          </a:xfrm>
+          <a:prstGeom prst="rect">
+            <a:avLst/>
+          </a:prstGeom>
+          <a:noFill/>
+        </p:spPr>
+        <p:txBody>
+          <a:bodyPr wrap="square">
+            <a:spAutoFit/>
+          </a:bodyPr>
+          <a:lstStyle/>
+          <a:p>
+            <a:pPr algn="l"/>
+            <a:r>
+              <a:rPr sz="950" b="0" i="1">
+                <a:solidFill>
+                  <a:srgbClr val="B2CCE8"/>
+                </a:solidFill>
+                <a:latin typeface="Calibri"/>
+              </a:rPr>
+              <a:t>Recommended minimum touch target: 48×48dp. Saral uses 88dp (1.83× the recommendation). Slide 7.</a:t>
+            </a:r>
+          </a:p>
+        </p:txBody>
+      </p:sp>
+      <p:sp>
+        <p:nvSpPr>
+          <p:cNvPr id="55" name="Rectangle 54"/>
+          <p:cNvSpPr/>
+          <p:nvPr/>
+        </p:nvSpPr>
+        <p:spPr>
+          <a:xfrm>
+            <a:off x="365760" y="6492240"/>
+            <a:ext cx="11430000" cy="256032"/>
+          </a:xfrm>
+          <a:prstGeom prst="rect">
+            <a:avLst/>
+          </a:prstGeom>
+          <a:solidFill>
+            <a:srgbClr val="040C18"/>
+          </a:solidFill>
+          <a:ln>
+            <a:noFill/>
+          </a:ln>
+        </p:spPr>
+        <p:style>
+          <a:lnRef idx="1">
+            <a:schemeClr val="accent1"/>
+          </a:lnRef>
+          <a:fillRef idx="3">
+            <a:schemeClr val="accent1"/>
+          </a:fillRef>
+          <a:effectRef idx="2">
+            <a:schemeClr val="accent1"/>
+          </a:effectRef>
+          <a:fontRef idx="minor">
+            <a:schemeClr val="lt1"/>
+          </a:fontRef>
+        </p:style>
+        <p:txBody>
+          <a:bodyPr rtlCol="0" anchor="ctr"/>
+          <a:lstStyle/>
+          <a:p>
+            <a:pPr algn="ctr"/>
+          </a:p>
+        </p:txBody>
+      </p:sp>
+      <p:sp>
+        <p:nvSpPr>
+          <p:cNvPr id="56" name="TextBox 55"/>
+          <p:cNvSpPr txBox="1"/>
+          <p:nvPr/>
+        </p:nvSpPr>
+        <p:spPr>
+          <a:xfrm>
+            <a:off x="457200" y="6510528"/>
+            <a:ext cx="11247120" cy="219456"/>
+          </a:xfrm>
+          <a:prstGeom prst="rect">
+            <a:avLst/>
+          </a:prstGeom>
+          <a:noFill/>
+        </p:spPr>
+        <p:txBody>
+          <a:bodyPr wrap="square">
+            <a:spAutoFit/>
+          </a:bodyPr>
+          <a:lstStyle/>
+          <a:p>
+            <a:pPr algn="ctr"/>
+            <a:r>
+              <a:rPr sz="900" b="0" i="1">
+                <a:solidFill>
+                  <a:srgbClr val="B2CCE8"/>
+                </a:solidFill>
+                <a:latin typeface="Calibri"/>
+              </a:rPr>
+              <a:t>All population figures are the best publicly available estimates at time of presentation. India-specific and global figures are distinguished in slide notes. Contrast ratios computed per WCAG 2.1 relative luminance formula.</a:t>
+            </a:r>
+          </a:p>
+        </p:txBody>
+      </p:sp>
+    </p:spTree>
+  </p:cSld>
+  <p:clrMapOvr>
+    <a:masterClrMapping/>
+  </p:clrMapOvr>
+</p:sld>
+</file>
+
 <file path=ppt/slides/slide2.xml><?xml version="1.0" encoding="utf-8"?>
 <p:sld xmlns:a="http://schemas.openxmlformats.org/drawingml/2006/main" xmlns:p="http://schemas.openxmlformats.org/presentationml/2006/main" xmlns:r="http://schemas.openxmlformats.org/officeDocument/2006/relationships">
   <p:cSld>
@@ -10194,8 +12338,7 @@
                 </a:solidFill>
                 <a:latin typeface="Calibri"/>
               </a:rPr>
-              <a:t>80M+ visually impaired Indians cannot read standard UI.
-Small fonts, low contrast, colour-coded status — completely inaccessible.</a:t>
+              <a:t>~72M Indians live with vision impairment or blindness (IAPB Vision Atlas 2023). Small fonts, low contrast, colour-coded status — completely inaccessible.</a:t>
             </a:r>
           </a:p>
         </p:txBody>
@@ -10388,8 +12531,7 @@
                 </a:solidFill>
                 <a:latin typeface="Calibri"/>
               </a:rPr>
-              <a:t>300M+ senior citizens struggle with precise taps on tiny buttons.
-Biometric auth required pressing a small 'Authenticate' button.</a:t>
+              <a:t>~145M senior citizens today (347M projected by 2050) struggle with precise taps on tiny buttons. Auto-biometric removes the biggest friction point.</a:t>
             </a:r>
           </a:p>
         </p:txBody>
@@ -10582,7 +12724,7 @@
                 </a:solidFill>
                 <a:latin typeface="Calibri"/>
               </a:rPr>
-              <a:t>400M+ rural users cannot navigate menu-driven interfaces or read account numbers and transaction text.</a:t>
+              <a:t>~372M Indians have limited literacy (Census 2011, 74% literacy rate on 1.43B population) — cannot navigate menu-driven interfaces.</a:t>
             </a:r>
           </a:p>
         </p:txBody>
@@ -10775,7 +12917,7 @@
                 </a:solidFill>
                 <a:latin typeface="Calibri"/>
               </a:rPr>
-              <a:t>300M+ colour-blind users cannot interpret red/green status used across virtually every banking app.</a:t>
+              <a:t>~300M people globally are colour-blind; ~60M in India (~8% of males). Red/green status indicators exclude them entirely.</a:t>
             </a:r>
           </a:p>
         </p:txBody>
@@ -11047,7 +13189,7 @@
                 </a:solidFill>
                 <a:latin typeface="Calibri"/>
               </a:rPr>
-              <a:t>80M+</a:t>
+              <a:t>~72M</a:t>
             </a:r>
           </a:p>
         </p:txBody>
@@ -11083,7 +13225,7 @@
                 <a:latin typeface="Calibri"/>
               </a:rPr>
               <a:t>Visually impaired
-Indians</a:t>
+Indians (IAPB 2023)</a:t>
             </a:r>
           </a:p>
         </p:txBody>
@@ -11163,7 +13305,7 @@
                 </a:solidFill>
                 <a:latin typeface="Calibri"/>
               </a:rPr>
-              <a:t>300M+</a:t>
+              <a:t>~60M</a:t>
             </a:r>
           </a:p>
         </p:txBody>
@@ -11199,7 +13341,7 @@
                 <a:latin typeface="Calibri"/>
               </a:rPr>
               <a:t>Colour-blind
-individuals</a:t>
+in India (~8% males)</a:t>
             </a:r>
           </a:p>
         </p:txBody>
@@ -11279,7 +13421,7 @@
                 </a:solidFill>
                 <a:latin typeface="Calibri"/>
               </a:rPr>
-              <a:t>300M+</a:t>
+              <a:t>145M+</a:t>
             </a:r>
           </a:p>
         </p:txBody>
@@ -11314,8 +13456,8 @@
                 </a:solidFill>
                 <a:latin typeface="Calibri"/>
               </a:rPr>
-              <a:t>Senior citizens
-(60+)</a:t>
+              <a:t>Senior citizens 60+
+(347M by 2050, UN)</a:t>
             </a:r>
           </a:p>
         </p:txBody>
@@ -11395,7 +13537,7 @@
                 </a:solidFill>
                 <a:latin typeface="Calibri"/>
               </a:rPr>
-              <a:t>400M+</a:t>
+              <a:t>~372M</a:t>
             </a:r>
           </a:p>
         </p:txBody>
@@ -11430,8 +13572,8 @@
                 </a:solidFill>
                 <a:latin typeface="Calibri"/>
               </a:rPr>
-              <a:t>Rural / low-literacy
-users</a:t>
+              <a:t>Limited literacy
+(Census 2011, 26%)</a:t>
             </a:r>
           </a:p>
         </p:txBody>
@@ -11466,7 +13608,7 @@
                 </a:solidFill>
                 <a:latin typeface="Calibri"/>
               </a:rPr>
-              <a:t>Source: Census of India, WHO Vision Report, NCD stats</a:t>
+              <a:t>Sources: IAPB Vision Atlas 2023 · Census of India 2011 · UN World Population Ageing 2023 · Colour Blind Awareness (colourblindawareness.org)  |  See References slide</a:t>
             </a:r>
           </a:p>
         </p:txBody>
@@ -12254,7 +14396,7 @@
                 </a:solidFill>
                 <a:latin typeface="Calibri"/>
               </a:rPr>
-              <a:t>15.8:1 contrast. Colour-blind safe palette. Full ARIA labels. Screen reader compatible.</a:t>
+              <a:t>18.7:1 contrast (WCAG AAA). Colour-blind safe palette. Full ARIA labels. Screen reader compatible.</a:t>
             </a:r>
           </a:p>
         </p:txBody>
@@ -17521,7 +19663,7 @@
                 </a:solidFill>
                 <a:latin typeface="Calibri"/>
               </a:rPr>
-              <a:t>Contrast  15.8:1</a:t>
+              <a:t>Contrast  18.7:1</a:t>
             </a:r>
           </a:p>
         </p:txBody>
@@ -18016,7 +20158,7 @@
                 </a:solidFill>
                 <a:latin typeface="Calibri"/>
               </a:rPr>
-              <a:t>Saral: 15.8:1 (AAA ✓)</a:t>
+              <a:t>Saral: 18.7:1 (AAA ✓)</a:t>
             </a:r>
           </a:p>
         </p:txBody>
@@ -20188,7 +22330,7 @@
                 </a:solidFill>
                 <a:latin typeface="Calibri"/>
               </a:rPr>
-              <a:t>10.9:1 on dark bg (AAA)</a:t>
+              <a:t>11.5:1 on dark bg (AAA)</a:t>
             </a:r>
           </a:p>
         </p:txBody>
@@ -20373,7 +22515,7 @@
                 </a:solidFill>
                 <a:latin typeface="Calibri"/>
               </a:rPr>
-              <a:t>On navy: 15.8:1 (AAA)</a:t>
+              <a:t>On navy: 18.7:1 (AAA)</a:t>
             </a:r>
           </a:p>
         </p:txBody>
@@ -20714,7 +22856,7 @@
                 </a:solidFill>
                 <a:latin typeface="Calibri"/>
               </a:rPr>
-              <a:t>Deuteranopia (green-blind, 5% of males): cannot distinguish green from red. Teal (#00BFA5) reads clearly as a distinct hue.  |  Protanopia (red-blind, 1% of males): cannot see red. Deep orange (#FF6B35) is visible across all colour-blindness types.  |  Amber (#FFC107) achieves 10.9:1 contrast on the dark navy background — exceeding WCAG AAA.</a:t>
+              <a:t>Deuteranopia (green-blind, ~4.6% of males — Colour Blind Awareness): cannot distinguish green from red. Teal (#00BFA5) reads clearly as a distinct hue to deuteranopes.  |  Protanopia (red-blind, ~1% of males): cannot see red hues. Deep orange (#FF6B35) is distinguishable across all colour-blindness types.  |  Amber (#FFC107) achieves 11.5:1 contrast on navy (WebAIM calculator) — exceeding WCAG AAA (7:1).</a:t>
             </a:r>
           </a:p>
         </p:txBody>

</xml_diff>